<commit_message>
feat: white mode added
</commit_message>
<xml_diff>
--- a/PROJECT_PRESENTATION.pptx
+++ b/PROJECT_PRESENTATION.pptx
@@ -3091,7 +3091,7 @@
     <p:bg>
       <p:bgPr>
         <a:solidFill>
-          <a:srgbClr val="F8FAFC"/>
+          <a:srgbClr val="FFFFFF"/>
         </a:solidFill>
         <a:effectLst/>
       </p:bgPr>
@@ -3111,18 +3111,18 @@
         </p:nvSpPr>
         <p:spPr>
           <a:xfrm>
-            <a:off x="1097280" y="1097280"/>
-            <a:ext cx="9997135" cy="4663440"/>
+            <a:off x="914400" y="914400"/>
+            <a:ext cx="10362895" cy="5029200"/>
           </a:xfrm>
           <a:prstGeom prst="roundRect">
             <a:avLst/>
           </a:prstGeom>
           <a:solidFill>
-            <a:srgbClr val="FFFFFF"/>
+            <a:srgbClr val="F8FAFC"/>
           </a:solidFill>
-          <a:ln w="19050">
+          <a:ln w="25400">
             <a:solidFill>
-              <a:srgbClr val="BAE6FD"/>
+              <a:srgbClr val="00875A"/>
             </a:solidFill>
           </a:ln>
         </p:spPr>
@@ -3145,14 +3145,14 @@
           <a:lstStyle/>
           <a:p>
             <a:pPr algn="ctr">
-              <a:defRPr sz="2800" b="1">
-                <a:solidFill>
-                  <a:srgbClr val="0284C7"/>
-                </a:solidFill>
-              </a:defRPr>
-            </a:pPr>
-            <a:r>
-              <a:t>GE VernovAI &amp; Decoupled LangGraph RAG</a:t>
+              <a:defRPr sz="1400" b="1">
+                <a:solidFill>
+                  <a:srgbClr val="00875A"/>
+                </a:solidFill>
+              </a:defRPr>
+            </a:pPr>
+            <a:r>
+              <a:t>GE VernovAI Platform Architecture</a:t>
             </a:r>
           </a:p>
           <a:p>
@@ -3160,30 +3160,45 @@
               <a:spcBef>
                 <a:spcPts val="1000"/>
               </a:spcBef>
+              <a:defRPr sz="3000" b="1">
+                <a:solidFill>
+                  <a:srgbClr val="0F172A"/>
+                </a:solidFill>
+              </a:defRPr>
+            </a:pPr>
+            <a:r>
+              <a:t>Enterprise Decoupled LangGraph RAG System</a:t>
+            </a:r>
+          </a:p>
+          <a:p>
+            <a:pPr algn="ctr">
+              <a:spcBef>
+                <a:spcPts val="800"/>
+              </a:spcBef>
               <a:defRPr sz="1600">
                 <a:solidFill>
-                  <a:srgbClr val="64748B"/>
-                </a:solidFill>
-              </a:defRPr>
-            </a:pPr>
-            <a:r>
-              <a:t>Enterprise Technical &amp; Executive Presentation Deck</a:t>
+                  <a:srgbClr val="0D9488"/>
+                </a:solidFill>
+              </a:defRPr>
+            </a:pPr>
+            <a:r>
+              <a:t>Systems Engineering Visual Intelligence &amp; Deterministic State Machine Execution</a:t>
             </a:r>
           </a:p>
           <a:p>
             <a:br/>
             <a:pPr algn="ctr">
               <a:spcBef>
-                <a:spcPts val="1500"/>
+                <a:spcPts val="1600"/>
               </a:spcBef>
               <a:defRPr sz="1300">
                 <a:solidFill>
-                  <a:srgbClr val="0F172A"/>
-                </a:solidFill>
-              </a:defRPr>
-            </a:pPr>
-            <a:r>
-              <a:t>High-performance Retrieval-Augmented Generation platform powered by LangChain, LangGraph Pregel state machines, FAISS vector indexing, and automated Senior Systems Engineering visual diagrams.</a:t>
+                  <a:srgbClr val="475569"/>
+                </a:solidFill>
+              </a:defRPr>
+            </a:pPr>
+            <a:r>
+              <a:t>Powered by LangChain, LangGraph Pregel state machine, FAISS vector indexing, and automated Senior Systems Engineering visual diagrams with zero-flicker SVG rendering.</a:t>
             </a:r>
           </a:p>
         </p:txBody>
@@ -3202,7 +3217,7 @@
     <p:bg>
       <p:bgPr>
         <a:solidFill>
-          <a:srgbClr val="F8FAFC"/>
+          <a:srgbClr val="FFFFFF"/>
         </a:solidFill>
         <a:effectLst/>
       </p:bgPr>
@@ -3239,12 +3254,12 @@
             <a:pPr>
               <a:defRPr sz="1000" b="1">
                 <a:solidFill>
-                  <a:srgbClr val="0284C7"/>
-                </a:solidFill>
-              </a:defRPr>
-            </a:pPr>
-            <a:r>
-              <a:t>EXECUTIVE OVERVIEW</a:t>
+                  <a:srgbClr val="00875A"/>
+                </a:solidFill>
+              </a:defRPr>
+            </a:pPr>
+            <a:r>
+              <a:t>GE VernovAI Platform  |  EXECUTIVE SUMMARY</a:t>
             </a:r>
           </a:p>
         </p:txBody>
@@ -3279,7 +3294,7 @@
               </a:defRPr>
             </a:pPr>
             <a:r>
-              <a:t>Business Challenge &amp; Core Value Proposition</a:t>
+              <a:t>Business Challenge &amp; GE VernovAI Solution</a:t>
             </a:r>
           </a:p>
         </p:txBody>
@@ -3293,13 +3308,13 @@
         <p:spPr>
           <a:xfrm>
             <a:off x="731520" y="1371600"/>
-            <a:ext cx="5120640" cy="4754880"/>
+            <a:ext cx="5120640" cy="4846320"/>
           </a:xfrm>
           <a:prstGeom prst="roundRect">
             <a:avLst/>
           </a:prstGeom>
           <a:solidFill>
-            <a:srgbClr val="FFFFFF"/>
+            <a:srgbClr val="F8FAFC"/>
           </a:solidFill>
           <a:ln w="19050">
             <a:solidFill>
@@ -3333,7 +3348,7 @@
               </a:defRPr>
             </a:pPr>
             <a:r>
-              <a:t>⚠️ Business Challenge</a:t>
+              <a:t>⚠️ Legacy Engineering Challenges</a:t>
             </a:r>
           </a:p>
           <a:p>
@@ -3348,7 +3363,7 @@
               </a:defRPr>
             </a:pPr>
             <a:r>
-              <a:t>• Complex engineering manuals &amp; technical specs siloed across dense unstructured PDFs.</a:t>
+              <a:t>• Complex GE engineering manuals &amp; technical specs siloed across dense unstructured PDFs.</a:t>
             </a:r>
           </a:p>
           <a:p>
@@ -3363,7 +3378,7 @@
               </a:defRPr>
             </a:pPr>
             <a:r>
-              <a:t>• Field engineers spend hours manually searching for turbine specs, electrical rules, and siting limits.</a:t>
+              <a:t>• Field engineers spend critical hours manually searching for turbine specs, electrical rules, and siting limits.</a:t>
             </a:r>
           </a:p>
           <a:p>
@@ -3378,7 +3393,7 @@
               </a:defRPr>
             </a:pPr>
             <a:r>
-              <a:t>• Standard LLM implementations suffer from hallucinations, data leakage, and diagram rendering crashes.</a:t>
+              <a:t>• Standard LLMs suffer from hallucinated parameters, data leakage, and diagram rendering crashes.</a:t>
             </a:r>
           </a:p>
         </p:txBody>
@@ -3392,17 +3407,17 @@
         <p:spPr>
           <a:xfrm>
             <a:off x="6217920" y="1371600"/>
-            <a:ext cx="5120640" cy="4754880"/>
+            <a:ext cx="5120640" cy="4846320"/>
           </a:xfrm>
           <a:prstGeom prst="roundRect">
             <a:avLst/>
           </a:prstGeom>
           <a:solidFill>
-            <a:srgbClr val="FFFFFF"/>
+            <a:srgbClr val="F8FAFC"/>
           </a:solidFill>
-          <a:ln w="19050">
+          <a:ln w="25400">
             <a:solidFill>
-              <a:srgbClr val="059669"/>
+              <a:srgbClr val="00875A"/>
             </a:solidFill>
           </a:ln>
         </p:spPr>
@@ -3427,12 +3442,12 @@
             <a:pPr algn="ctr">
               <a:defRPr sz="1600" b="1">
                 <a:solidFill>
-                  <a:srgbClr val="059669"/>
-                </a:solidFill>
-              </a:defRPr>
-            </a:pPr>
-            <a:r>
-              <a:t>💡 The GE VernovAI Solution</a:t>
+                  <a:srgbClr val="00875A"/>
+                </a:solidFill>
+              </a:defRPr>
+            </a:pPr>
+            <a:r>
+              <a:t>💡 GE VernovAI Solution</a:t>
             </a:r>
           </a:p>
           <a:p>
@@ -3492,7 +3507,7 @@
               </a:defRPr>
             </a:pPr>
             <a:r>
-              <a:t>✓ Zero-Trust Security: Confidentiality guards, AST string sanitizers, and offline fallback capability.</a:t>
+              <a:t>✓ Zero-Trust Guardrails: Confidentiality guards, AST string sanitizers, and offline fallback capability.</a:t>
             </a:r>
           </a:p>
         </p:txBody>
@@ -3511,7 +3526,7 @@
     <p:bg>
       <p:bgPr>
         <a:solidFill>
-          <a:srgbClr val="F8FAFC"/>
+          <a:srgbClr val="FFFFFF"/>
         </a:solidFill>
         <a:effectLst/>
       </p:bgPr>
@@ -3548,12 +3563,12 @@
             <a:pPr>
               <a:defRPr sz="1000" b="1">
                 <a:solidFill>
-                  <a:srgbClr val="0284C7"/>
-                </a:solidFill>
-              </a:defRPr>
-            </a:pPr>
-            <a:r>
-              <a:t>ARCHITECTURE FLOW</a:t>
+                  <a:srgbClr val="00875A"/>
+                </a:solidFill>
+              </a:defRPr>
+            </a:pPr>
+            <a:r>
+              <a:t>GE VernovAI Platform  |  SYSTEM ARCHITECTURE</a:t>
             </a:r>
           </a:p>
         </p:txBody>
@@ -3588,7 +3603,7 @@
               </a:defRPr>
             </a:pPr>
             <a:r>
-              <a:t>High-Level End-to-End System Pipeline</a:t>
+              <a:t>High-Level GE VernovAI End-to-End Flow</a:t>
             </a:r>
           </a:p>
         </p:txBody>
@@ -3608,11 +3623,11 @@
             <a:avLst/>
           </a:prstGeom>
           <a:solidFill>
-            <a:srgbClr val="FFFFFF"/>
+            <a:srgbClr val="F8FAFC"/>
           </a:solidFill>
-          <a:ln w="15240">
+          <a:ln w="19050">
             <a:solidFill>
-              <a:srgbClr val="0284C7"/>
+              <a:srgbClr val="00875A"/>
             </a:solidFill>
           </a:ln>
         </p:spPr>
@@ -3637,7 +3652,7 @@
             <a:pPr algn="ctr">
               <a:defRPr sz="1200" b="1">
                 <a:solidFill>
-                  <a:srgbClr val="0284C7"/>
+                  <a:srgbClr val="00875A"/>
                 </a:solidFill>
               </a:defRPr>
             </a:pPr>
@@ -3652,7 +3667,7 @@
               </a:spcBef>
               <a:defRPr sz="1000">
                 <a:solidFill>
-                  <a:srgbClr val="64748B"/>
+                  <a:srgbClr val="475569"/>
                 </a:solidFill>
               </a:defRPr>
             </a:pPr>
@@ -3677,11 +3692,11 @@
             <a:avLst/>
           </a:prstGeom>
           <a:solidFill>
-            <a:srgbClr val="FFFFFF"/>
+            <a:srgbClr val="F8FAFC"/>
           </a:solidFill>
-          <a:ln w="15240">
+          <a:ln w="19050">
             <a:solidFill>
-              <a:srgbClr val="0284C7"/>
+              <a:srgbClr val="00875A"/>
             </a:solidFill>
           </a:ln>
         </p:spPr>
@@ -3706,7 +3721,7 @@
             <a:pPr algn="ctr">
               <a:defRPr sz="1200" b="1">
                 <a:solidFill>
-                  <a:srgbClr val="0284C7"/>
+                  <a:srgbClr val="00875A"/>
                 </a:solidFill>
               </a:defRPr>
             </a:pPr>
@@ -3721,7 +3736,7 @@
               </a:spcBef>
               <a:defRPr sz="1000">
                 <a:solidFill>
-                  <a:srgbClr val="64748B"/>
+                  <a:srgbClr val="475569"/>
                 </a:solidFill>
               </a:defRPr>
             </a:pPr>
@@ -3746,11 +3761,11 @@
             <a:avLst/>
           </a:prstGeom>
           <a:solidFill>
-            <a:srgbClr val="FFFFFF"/>
+            <a:srgbClr val="F8FAFC"/>
           </a:solidFill>
-          <a:ln w="15240">
+          <a:ln w="19050">
             <a:solidFill>
-              <a:srgbClr val="0284C7"/>
+              <a:srgbClr val="00875A"/>
             </a:solidFill>
           </a:ln>
         </p:spPr>
@@ -3775,7 +3790,7 @@
             <a:pPr algn="ctr">
               <a:defRPr sz="1200" b="1">
                 <a:solidFill>
-                  <a:srgbClr val="0284C7"/>
+                  <a:srgbClr val="00875A"/>
                 </a:solidFill>
               </a:defRPr>
             </a:pPr>
@@ -3790,7 +3805,7 @@
               </a:spcBef>
               <a:defRPr sz="1000">
                 <a:solidFill>
-                  <a:srgbClr val="64748B"/>
+                  <a:srgbClr val="475569"/>
                 </a:solidFill>
               </a:defRPr>
             </a:pPr>
@@ -3815,11 +3830,11 @@
             <a:avLst/>
           </a:prstGeom>
           <a:solidFill>
-            <a:srgbClr val="FFFFFF"/>
+            <a:srgbClr val="F8FAFC"/>
           </a:solidFill>
-          <a:ln w="15240">
+          <a:ln w="19050">
             <a:solidFill>
-              <a:srgbClr val="0284C7"/>
+              <a:srgbClr val="00875A"/>
             </a:solidFill>
           </a:ln>
         </p:spPr>
@@ -3844,7 +3859,7 @@
             <a:pPr algn="ctr">
               <a:defRPr sz="1200" b="1">
                 <a:solidFill>
-                  <a:srgbClr val="0284C7"/>
+                  <a:srgbClr val="00875A"/>
                 </a:solidFill>
               </a:defRPr>
             </a:pPr>
@@ -3859,7 +3874,7 @@
               </a:spcBef>
               <a:defRPr sz="1000">
                 <a:solidFill>
-                  <a:srgbClr val="64748B"/>
+                  <a:srgbClr val="475569"/>
                 </a:solidFill>
               </a:defRPr>
             </a:pPr>
@@ -3884,11 +3899,11 @@
             <a:avLst/>
           </a:prstGeom>
           <a:solidFill>
-            <a:srgbClr val="FFFFFF"/>
+            <a:srgbClr val="F8FAFC"/>
           </a:solidFill>
-          <a:ln w="15240">
+          <a:ln w="19050">
             <a:solidFill>
-              <a:srgbClr val="4F46E5"/>
+              <a:srgbClr val="0D9488"/>
             </a:solidFill>
           </a:ln>
         </p:spPr>
@@ -3913,7 +3928,7 @@
             <a:pPr algn="ctr">
               <a:defRPr sz="1200" b="1">
                 <a:solidFill>
-                  <a:srgbClr val="4F46E5"/>
+                  <a:srgbClr val="0D9488"/>
                 </a:solidFill>
               </a:defRPr>
             </a:pPr>
@@ -3928,7 +3943,7 @@
               </a:spcBef>
               <a:defRPr sz="1000">
                 <a:solidFill>
-                  <a:srgbClr val="64748B"/>
+                  <a:srgbClr val="475569"/>
                 </a:solidFill>
               </a:defRPr>
             </a:pPr>
@@ -3953,11 +3968,11 @@
             <a:avLst/>
           </a:prstGeom>
           <a:solidFill>
-            <a:srgbClr val="FFFFFF"/>
+            <a:srgbClr val="F8FAFC"/>
           </a:solidFill>
-          <a:ln w="15240">
+          <a:ln w="19050">
             <a:solidFill>
-              <a:srgbClr val="4F46E5"/>
+              <a:srgbClr val="0D9488"/>
             </a:solidFill>
           </a:ln>
         </p:spPr>
@@ -3982,7 +3997,7 @@
             <a:pPr algn="ctr">
               <a:defRPr sz="1200" b="1">
                 <a:solidFill>
-                  <a:srgbClr val="4F46E5"/>
+                  <a:srgbClr val="0D9488"/>
                 </a:solidFill>
               </a:defRPr>
             </a:pPr>
@@ -3997,7 +4012,7 @@
               </a:spcBef>
               <a:defRPr sz="1000">
                 <a:solidFill>
-                  <a:srgbClr val="64748B"/>
+                  <a:srgbClr val="475569"/>
                 </a:solidFill>
               </a:defRPr>
             </a:pPr>
@@ -4022,11 +4037,11 @@
             <a:avLst/>
           </a:prstGeom>
           <a:solidFill>
-            <a:srgbClr val="FFFFFF"/>
+            <a:srgbClr val="F8FAFC"/>
           </a:solidFill>
-          <a:ln w="15240">
+          <a:ln w="19050">
             <a:solidFill>
-              <a:srgbClr val="4F46E5"/>
+              <a:srgbClr val="0D9488"/>
             </a:solidFill>
           </a:ln>
         </p:spPr>
@@ -4051,7 +4066,7 @@
             <a:pPr algn="ctr">
               <a:defRPr sz="1200" b="1">
                 <a:solidFill>
-                  <a:srgbClr val="4F46E5"/>
+                  <a:srgbClr val="0D9488"/>
                 </a:solidFill>
               </a:defRPr>
             </a:pPr>
@@ -4066,7 +4081,7 @@
               </a:spcBef>
               <a:defRPr sz="1000">
                 <a:solidFill>
-                  <a:srgbClr val="64748B"/>
+                  <a:srgbClr val="475569"/>
                 </a:solidFill>
               </a:defRPr>
             </a:pPr>
@@ -4091,11 +4106,11 @@
             <a:avLst/>
           </a:prstGeom>
           <a:solidFill>
-            <a:srgbClr val="FFFFFF"/>
+            <a:srgbClr val="F8FAFC"/>
           </a:solidFill>
-          <a:ln w="15240">
+          <a:ln w="19050">
             <a:solidFill>
-              <a:srgbClr val="4F46E5"/>
+              <a:srgbClr val="0D9488"/>
             </a:solidFill>
           </a:ln>
         </p:spPr>
@@ -4120,7 +4135,7 @@
             <a:pPr algn="ctr">
               <a:defRPr sz="1200" b="1">
                 <a:solidFill>
-                  <a:srgbClr val="4F46E5"/>
+                  <a:srgbClr val="0D9488"/>
                 </a:solidFill>
               </a:defRPr>
             </a:pPr>
@@ -4135,7 +4150,7 @@
               </a:spcBef>
               <a:defRPr sz="1000">
                 <a:solidFill>
-                  <a:srgbClr val="64748B"/>
+                  <a:srgbClr val="475569"/>
                 </a:solidFill>
               </a:defRPr>
             </a:pPr>
@@ -4159,7 +4174,7 @@
     <p:bg>
       <p:bgPr>
         <a:solidFill>
-          <a:srgbClr val="F8FAFC"/>
+          <a:srgbClr val="FFFFFF"/>
         </a:solidFill>
         <a:effectLst/>
       </p:bgPr>
@@ -4196,12 +4211,12 @@
             <a:pPr>
               <a:defRPr sz="1000" b="1">
                 <a:solidFill>
-                  <a:srgbClr val="0284C7"/>
-                </a:solidFill>
-              </a:defRPr>
-            </a:pPr>
-            <a:r>
-              <a:t>PREGEL EXECUTION ENGINE</a:t>
+                  <a:srgbClr val="00875A"/>
+                </a:solidFill>
+              </a:defRPr>
+            </a:pPr>
+            <a:r>
+              <a:t>GE VernovAI Platform  |  PREGEL STATE ENGINE</a:t>
             </a:r>
           </a:p>
         </p:txBody>
@@ -4256,11 +4271,11 @@
             <a:avLst/>
           </a:prstGeom>
           <a:solidFill>
-            <a:srgbClr val="FFFFFF"/>
+            <a:srgbClr val="F8FAFC"/>
           </a:solidFill>
-          <a:ln w="15240">
+          <a:ln w="19050">
             <a:solidFill>
-              <a:srgbClr val="4F46E5"/>
+              <a:srgbClr val="0284C7"/>
             </a:solidFill>
           </a:ln>
         </p:spPr>
@@ -4300,12 +4315,12 @@
               </a:spcBef>
               <a:defRPr sz="1000">
                 <a:solidFill>
-                  <a:srgbClr val="64748B"/>
-                </a:solidFill>
-              </a:defRPr>
-            </a:pPr>
-            <a:r>
-              <a:t>JSON schema validation &amp; thread state</a:t>
+                  <a:srgbClr val="475569"/>
+                </a:solidFill>
+              </a:defRPr>
+            </a:pPr>
+            <a:r>
+              <a:t>JSON schema validation &amp; session state</a:t>
             </a:r>
           </a:p>
         </p:txBody>
@@ -4325,11 +4340,11 @@
             <a:avLst/>
           </a:prstGeom>
           <a:solidFill>
-            <a:srgbClr val="FFFFFF"/>
+            <a:srgbClr val="F8FAFC"/>
           </a:solidFill>
-          <a:ln w="15240">
+          <a:ln w="19050">
             <a:solidFill>
-              <a:srgbClr val="4F46E5"/>
+              <a:srgbClr val="0284C7"/>
             </a:solidFill>
           </a:ln>
         </p:spPr>
@@ -4369,7 +4384,7 @@
               </a:spcBef>
               <a:defRPr sz="1000">
                 <a:solidFill>
-                  <a:srgbClr val="64748B"/>
+                  <a:srgbClr val="475569"/>
                 </a:solidFill>
               </a:defRPr>
             </a:pPr>
@@ -4394,11 +4409,11 @@
             <a:avLst/>
           </a:prstGeom>
           <a:solidFill>
-            <a:srgbClr val="FFFFFF"/>
+            <a:srgbClr val="F8FAFC"/>
           </a:solidFill>
-          <a:ln w="15240">
+          <a:ln w="19050">
             <a:solidFill>
-              <a:srgbClr val="4F46E5"/>
+              <a:srgbClr val="0284C7"/>
             </a:solidFill>
           </a:ln>
         </p:spPr>
@@ -4438,7 +4453,7 @@
               </a:spcBef>
               <a:defRPr sz="1000">
                 <a:solidFill>
-                  <a:srgbClr val="64748B"/>
+                  <a:srgbClr val="475569"/>
                 </a:solidFill>
               </a:defRPr>
             </a:pPr>
@@ -4463,11 +4478,11 @@
             <a:avLst/>
           </a:prstGeom>
           <a:solidFill>
-            <a:srgbClr val="FFFFFF"/>
+            <a:srgbClr val="F8FAFC"/>
           </a:solidFill>
-          <a:ln w="15240">
+          <a:ln w="19050">
             <a:solidFill>
-              <a:srgbClr val="4F46E5"/>
+              <a:srgbClr val="0284C7"/>
             </a:solidFill>
           </a:ln>
         </p:spPr>
@@ -4507,7 +4522,7 @@
               </a:spcBef>
               <a:defRPr sz="1000">
                 <a:solidFill>
-                  <a:srgbClr val="64748B"/>
+                  <a:srgbClr val="475569"/>
                 </a:solidFill>
               </a:defRPr>
             </a:pPr>
@@ -4532,11 +4547,11 @@
             <a:avLst/>
           </a:prstGeom>
           <a:solidFill>
-            <a:srgbClr val="FFFFFF"/>
+            <a:srgbClr val="F8FAFC"/>
           </a:solidFill>
-          <a:ln w="15240">
+          <a:ln w="19050">
             <a:solidFill>
-              <a:srgbClr val="4F46E5"/>
+              <a:srgbClr val="0284C7"/>
             </a:solidFill>
           </a:ln>
         </p:spPr>
@@ -4576,7 +4591,7 @@
               </a:spcBef>
               <a:defRPr sz="1000">
                 <a:solidFill>
-                  <a:srgbClr val="64748B"/>
+                  <a:srgbClr val="475569"/>
                 </a:solidFill>
               </a:defRPr>
             </a:pPr>
@@ -4601,11 +4616,11 @@
             <a:avLst/>
           </a:prstGeom>
           <a:solidFill>
-            <a:srgbClr val="FFFFFF"/>
+            <a:srgbClr val="F8FAFC"/>
           </a:solidFill>
-          <a:ln w="15240">
+          <a:ln w="19050">
             <a:solidFill>
-              <a:srgbClr val="4F46E5"/>
+              <a:srgbClr val="0284C7"/>
             </a:solidFill>
           </a:ln>
         </p:spPr>
@@ -4645,7 +4660,7 @@
               </a:spcBef>
               <a:defRPr sz="1000">
                 <a:solidFill>
-                  <a:srgbClr val="64748B"/>
+                  <a:srgbClr val="475569"/>
                 </a:solidFill>
               </a:defRPr>
             </a:pPr>
@@ -4670,11 +4685,11 @@
             <a:avLst/>
           </a:prstGeom>
           <a:solidFill>
-            <a:srgbClr val="FFFFFF"/>
+            <a:srgbClr val="F8FAFC"/>
           </a:solidFill>
-          <a:ln w="15240">
+          <a:ln w="19050">
             <a:solidFill>
-              <a:srgbClr val="059669"/>
+              <a:srgbClr val="00875A"/>
             </a:solidFill>
           </a:ln>
         </p:spPr>
@@ -4714,7 +4729,7 @@
               </a:spcBef>
               <a:defRPr sz="1000">
                 <a:solidFill>
-                  <a:srgbClr val="64748B"/>
+                  <a:srgbClr val="475569"/>
                 </a:solidFill>
               </a:defRPr>
             </a:pPr>
@@ -4739,11 +4754,11 @@
             <a:avLst/>
           </a:prstGeom>
           <a:solidFill>
-            <a:srgbClr val="FFFFFF"/>
+            <a:srgbClr val="F8FAFC"/>
           </a:solidFill>
-          <a:ln w="15240">
+          <a:ln w="19050">
             <a:solidFill>
-              <a:srgbClr val="059669"/>
+              <a:srgbClr val="00875A"/>
             </a:solidFill>
           </a:ln>
         </p:spPr>
@@ -4783,7 +4798,7 @@
               </a:spcBef>
               <a:defRPr sz="1000">
                 <a:solidFill>
-                  <a:srgbClr val="64748B"/>
+                  <a:srgbClr val="475569"/>
                 </a:solidFill>
               </a:defRPr>
             </a:pPr>
@@ -4807,7 +4822,7 @@
     <p:bg>
       <p:bgPr>
         <a:solidFill>
-          <a:srgbClr val="F8FAFC"/>
+          <a:srgbClr val="FFFFFF"/>
         </a:solidFill>
         <a:effectLst/>
       </p:bgPr>
@@ -4844,12 +4859,12 @@
             <a:pPr>
               <a:defRPr sz="1000" b="1">
                 <a:solidFill>
-                  <a:srgbClr val="0284C7"/>
-                </a:solidFill>
-              </a:defRPr>
-            </a:pPr>
-            <a:r>
-              <a:t>ENTERPRISE INTEGRITY</a:t>
+                  <a:srgbClr val="00875A"/>
+                </a:solidFill>
+              </a:defRPr>
+            </a:pPr>
+            <a:r>
+              <a:t>GE VernovAI Platform  |  ENTERPRISE SECURITY</a:t>
             </a:r>
           </a:p>
         </p:txBody>
@@ -4884,7 +4899,7 @@
               </a:defRPr>
             </a:pPr>
             <a:r>
-              <a:t>4-Layer Security &amp; Fallback Resilience</a:t>
+              <a:t>4-Layer Fallback Resilience &amp; Safety Shields</a:t>
             </a:r>
           </a:p>
         </p:txBody>
@@ -4904,11 +4919,11 @@
             <a:avLst/>
           </a:prstGeom>
           <a:solidFill>
-            <a:srgbClr val="FFFFFF"/>
+            <a:srgbClr val="F8FAFC"/>
           </a:solidFill>
           <a:ln w="19050">
             <a:solidFill>
-              <a:srgbClr val="059669"/>
+              <a:srgbClr val="00875A"/>
             </a:solidFill>
           </a:ln>
         </p:spPr>
@@ -4933,7 +4948,7 @@
             <a:pPr algn="ctr">
               <a:defRPr sz="1400" b="1">
                 <a:solidFill>
-                  <a:srgbClr val="059669"/>
+                  <a:srgbClr val="00875A"/>
                 </a:solidFill>
               </a:defRPr>
             </a:pPr>
@@ -4973,7 +4988,7 @@
             <a:avLst/>
           </a:prstGeom>
           <a:solidFill>
-            <a:srgbClr val="FFFFFF"/>
+            <a:srgbClr val="F8FAFC"/>
           </a:solidFill>
           <a:ln w="19050">
             <a:solidFill>
@@ -5042,11 +5057,11 @@
             <a:avLst/>
           </a:prstGeom>
           <a:solidFill>
-            <a:srgbClr val="FFFFFF"/>
+            <a:srgbClr val="F8FAFC"/>
           </a:solidFill>
           <a:ln w="19050">
             <a:solidFill>
-              <a:srgbClr val="4F46E5"/>
+              <a:srgbClr val="0D9488"/>
             </a:solidFill>
           </a:ln>
         </p:spPr>
@@ -5071,7 +5086,7 @@
             <a:pPr algn="ctr">
               <a:defRPr sz="1400" b="1">
                 <a:solidFill>
-                  <a:srgbClr val="4F46E5"/>
+                  <a:srgbClr val="0D9488"/>
                 </a:solidFill>
               </a:defRPr>
             </a:pPr>
@@ -5111,7 +5126,7 @@
             <a:avLst/>
           </a:prstGeom>
           <a:solidFill>
-            <a:srgbClr val="FFFFFF"/>
+            <a:srgbClr val="F8FAFC"/>
           </a:solidFill>
           <a:ln w="19050">
             <a:solidFill>
@@ -5179,7 +5194,7 @@
     <p:bg>
       <p:bgPr>
         <a:solidFill>
-          <a:srgbClr val="F8FAFC"/>
+          <a:srgbClr val="FFFFFF"/>
         </a:solidFill>
         <a:effectLst/>
       </p:bgPr>
@@ -5216,12 +5231,12 @@
             <a:pPr>
               <a:defRPr sz="1000" b="1">
                 <a:solidFill>
-                  <a:srgbClr val="0284C7"/>
-                </a:solidFill>
-              </a:defRPr>
-            </a:pPr>
-            <a:r>
-              <a:t>AUTOMATED VISUAL INTELLIGENCE</a:t>
+                  <a:srgbClr val="00875A"/>
+                </a:solidFill>
+              </a:defRPr>
+            </a:pPr>
+            <a:r>
+              <a:t>GE VernovAI Platform  |  VISUAL INTELLIGENCE</a:t>
             </a:r>
           </a:p>
         </p:txBody>
@@ -5256,7 +5271,7 @@
               </a:defRPr>
             </a:pPr>
             <a:r>
-              <a:t>Senior Systems Engineering Diagram Output</a:t>
+              <a:t>Senior Systems Engineering Automated Output</a:t>
             </a:r>
           </a:p>
         </p:txBody>
@@ -5270,17 +5285,17 @@
         <p:spPr>
           <a:xfrm>
             <a:off x="731520" y="1371600"/>
-            <a:ext cx="10698480" cy="4754880"/>
+            <a:ext cx="10698480" cy="4846320"/>
           </a:xfrm>
           <a:prstGeom prst="roundRect">
             <a:avLst/>
           </a:prstGeom>
           <a:solidFill>
-            <a:srgbClr val="FFFFFF"/>
+            <a:srgbClr val="F8FAFC"/>
           </a:solidFill>
-          <a:ln w="12700">
+          <a:ln w="25400">
             <a:solidFill>
-              <a:srgbClr val="E2E8F0"/>
+              <a:srgbClr val="00875A"/>
             </a:solidFill>
           </a:ln>
         </p:spPr>
@@ -5303,20 +5318,20 @@
           <a:lstStyle/>
           <a:p>
             <a:pPr algn="ctr">
-              <a:defRPr sz="1400" b="1">
-                <a:solidFill>
-                  <a:srgbClr val="0284C7"/>
-                </a:solidFill>
-              </a:defRPr>
-            </a:pPr>
-            <a:r>
-              <a:t>Sample Systems Diagram: Small Wind Turbine Architecture (Model LN3500)</a:t>
+              <a:defRPr sz="1500" b="1">
+                <a:solidFill>
+                  <a:srgbClr val="00875A"/>
+                </a:solidFill>
+              </a:defRPr>
+            </a:pPr>
+            <a:r>
+              <a:t>Sample Output: Small Wind Turbine Architecture (Model LN3500)</a:t>
             </a:r>
           </a:p>
           <a:p>
             <a:pPr>
               <a:spcBef>
-                <a:spcPts val="1200"/>
+                <a:spcPts val="1400"/>
               </a:spcBef>
               <a:defRPr sz="1200">
                 <a:solidFill>
@@ -5331,7 +5346,7 @@
           <a:p>
             <a:pPr>
               <a:spcBef>
-                <a:spcPts val="1200"/>
+                <a:spcPts val="1400"/>
               </a:spcBef>
               <a:defRPr sz="1200">
                 <a:solidFill>
@@ -5346,7 +5361,7 @@
           <a:p>
             <a:pPr>
               <a:spcBef>
-                <a:spcPts val="1200"/>
+                <a:spcPts val="1400"/>
               </a:spcBef>
               <a:defRPr sz="1200">
                 <a:solidFill>
@@ -5361,7 +5376,7 @@
           <a:p>
             <a:pPr>
               <a:spcBef>
-                <a:spcPts val="1200"/>
+                <a:spcPts val="1400"/>
               </a:spcBef>
               <a:defRPr sz="1200">
                 <a:solidFill>
@@ -5389,7 +5404,7 @@
     <p:bg>
       <p:bgPr>
         <a:solidFill>
-          <a:srgbClr val="F8FAFC"/>
+          <a:srgbClr val="FFFFFF"/>
         </a:solidFill>
         <a:effectLst/>
       </p:bgPr>
@@ -5426,12 +5441,12 @@
             <a:pPr>
               <a:defRPr sz="1000" b="1">
                 <a:solidFill>
-                  <a:srgbClr val="0284C7"/>
-                </a:solidFill>
-              </a:defRPr>
-            </a:pPr>
-            <a:r>
-              <a:t>SYSTEM BENCHMARKS</a:t>
+                  <a:srgbClr val="00875A"/>
+                </a:solidFill>
+              </a:defRPr>
+            </a:pPr>
+            <a:r>
+              <a:t>GE VernovAI Platform  |  SYSTEM PERFORMANCE</a:t>
             </a:r>
           </a:p>
         </p:txBody>
@@ -5466,7 +5481,7 @@
               </a:defRPr>
             </a:pPr>
             <a:r>
-              <a:t>Performance Metrics &amp; Zero-Flicker Stability</a:t>
+              <a:t>Performance Metrics &amp; Zero-Flicker Diagram Stability</a:t>
             </a:r>
           </a:p>
         </p:txBody>
@@ -5486,7 +5501,7 @@
             <a:avLst/>
           </a:prstGeom>
           <a:solidFill>
-            <a:srgbClr val="FFFFFF"/>
+            <a:srgbClr val="F8FAFC"/>
           </a:solidFill>
           <a:ln w="25400">
             <a:solidFill>
@@ -5545,7 +5560,7 @@
               </a:spcBef>
               <a:defRPr sz="1100">
                 <a:solidFill>
-                  <a:srgbClr val="64748B"/>
+                  <a:srgbClr val="475569"/>
                 </a:solidFill>
               </a:defRPr>
             </a:pPr>
@@ -5570,11 +5585,11 @@
             <a:avLst/>
           </a:prstGeom>
           <a:solidFill>
-            <a:srgbClr val="FFFFFF"/>
+            <a:srgbClr val="F8FAFC"/>
           </a:solidFill>
           <a:ln w="25400">
             <a:solidFill>
-              <a:srgbClr val="4F46E5"/>
+              <a:srgbClr val="0D9488"/>
             </a:solidFill>
           </a:ln>
         </p:spPr>
@@ -5599,7 +5614,7 @@
             <a:pPr algn="ctr">
               <a:defRPr sz="3600" b="1">
                 <a:solidFill>
-                  <a:srgbClr val="4F46E5"/>
+                  <a:srgbClr val="0D9488"/>
                 </a:solidFill>
               </a:defRPr>
             </a:pPr>
@@ -5629,7 +5644,7 @@
               </a:spcBef>
               <a:defRPr sz="1100">
                 <a:solidFill>
-                  <a:srgbClr val="64748B"/>
+                  <a:srgbClr val="475569"/>
                 </a:solidFill>
               </a:defRPr>
             </a:pPr>
@@ -5654,11 +5669,11 @@
             <a:avLst/>
           </a:prstGeom>
           <a:solidFill>
-            <a:srgbClr val="FFFFFF"/>
+            <a:srgbClr val="F8FAFC"/>
           </a:solidFill>
           <a:ln w="25400">
             <a:solidFill>
-              <a:srgbClr val="059669"/>
+              <a:srgbClr val="00875A"/>
             </a:solidFill>
           </a:ln>
         </p:spPr>
@@ -5683,7 +5698,7 @@
             <a:pPr algn="ctr">
               <a:defRPr sz="3600" b="1">
                 <a:solidFill>
-                  <a:srgbClr val="059669"/>
+                  <a:srgbClr val="00875A"/>
                 </a:solidFill>
               </a:defRPr>
             </a:pPr>
@@ -5713,7 +5728,7 @@
               </a:spcBef>
               <a:defRPr sz="1100">
                 <a:solidFill>
-                  <a:srgbClr val="64748B"/>
+                  <a:srgbClr val="475569"/>
                 </a:solidFill>
               </a:defRPr>
             </a:pPr>
@@ -5737,7 +5752,7 @@
     <p:bg>
       <p:bgPr>
         <a:solidFill>
-          <a:srgbClr val="F8FAFC"/>
+          <a:srgbClr val="FFFFFF"/>
         </a:solidFill>
         <a:effectLst/>
       </p:bgPr>
@@ -5774,12 +5789,12 @@
             <a:pPr>
               <a:defRPr sz="1000" b="1">
                 <a:solidFill>
-                  <a:srgbClr val="0284C7"/>
-                </a:solidFill>
-              </a:defRPr>
-            </a:pPr>
-            <a:r>
-              <a:t>PRODUCTION INTEGRATION</a:t>
+                  <a:srgbClr val="00875A"/>
+                </a:solidFill>
+              </a:defRPr>
+            </a:pPr>
+            <a:r>
+              <a:t>GE VernovAI Platform  |  PRODUCTION INTEGRATION</a:t>
             </a:r>
           </a:p>
         </p:txBody>
@@ -5834,7 +5849,7 @@
             <a:avLst/>
           </a:prstGeom>
           <a:solidFill>
-            <a:srgbClr val="FFFFFF"/>
+            <a:srgbClr val="F8FAFC"/>
           </a:solidFill>
           <a:ln w="19050">
             <a:solidFill>
@@ -5911,11 +5926,11 @@
             <a:avLst/>
           </a:prstGeom>
           <a:solidFill>
-            <a:srgbClr val="FFFFFF"/>
+            <a:srgbClr val="F8FAFC"/>
           </a:solidFill>
           <a:ln w="19050">
             <a:solidFill>
-              <a:srgbClr val="059669"/>
+              <a:srgbClr val="00875A"/>
             </a:solidFill>
           </a:ln>
         </p:spPr>
@@ -5940,7 +5955,7 @@
             <a:pPr algn="ctr">
               <a:defRPr sz="1600" b="1">
                 <a:solidFill>
-                  <a:srgbClr val="059669"/>
+                  <a:srgbClr val="00875A"/>
                 </a:solidFill>
               </a:defRPr>
             </a:pPr>

</xml_diff>